<commit_message>
chore: repo cleanup — fix links, remove GFM duplicates, disable dead workflows, add styled templates
Summary of changes:
- Fix 13 broken .md cross-references in .qmd files → updated to .qmd
- Remove 13 GFM duplicate files (docs/*-gfm.qmd variants)
- Disable 12 legacy/redundant workflows (set to workflow_dispatch only)
  - ai-security-audit, canon-validation, ci, deploy, drift-detection,
    generate-artifacts, generate-docs, generate_artifacts, lint,
    render-and-insert-diagrams, publish, push-adapters-workflow
  - rename-visuals annotated as deprecated (already workflow_dispatch)
- Replace data/docx-reference.docx with styled Microsoft Learn template
  (Calibri, navy headings, styled code blocks, table headers)
- Replace data/pptx-reference.pptx with styled branded template
  (16:9, navy bars, teal accents, 5 slide layouts)
</commit_message>
<xml_diff>
--- a/data/pptx-reference.pptx
+++ b/data/pptx-reference.pptx
@@ -6,6 +6,10 @@
   </p:sldMasterIdLst>
   <p:sldIdLst>
     <p:sldId id="256" r:id="rId7"/>
+    <p:sldId id="257" r:id="rId8"/>
+    <p:sldId id="258" r:id="rId9"/>
+    <p:sldId id="259" r:id="rId10"/>
+    <p:sldId id="260" r:id="rId11"/>
   </p:sldIdLst>
   <p:sldSz cx="12191695" cy="6858000" type="screen4x3"/>
   <p:notesSz cx="6858000" cy="9144000"/>
@@ -3081,6 +3085,14 @@
 <file path=ppt/slides/slide1.xml><?xml version="1.0" encoding="utf-8"?>
 <p:sld xmlns:a="http://schemas.openxmlformats.org/drawingml/2006/main" xmlns:p="http://schemas.openxmlformats.org/presentationml/2006/main" xmlns:r="http://schemas.openxmlformats.org/officeDocument/2006/relationships">
   <p:cSld>
+    <p:bg>
+      <p:bgPr>
+        <a:solidFill>
+          <a:srgbClr val="003B6F"/>
+        </a:solidFill>
+        <a:effectLst/>
+      </p:bgPr>
+    </p:bg>
     <p:spTree>
       <p:nvGrpSpPr>
         <p:cNvPr id="1" name=""/>
@@ -3090,25 +3102,35 @@
       <p:grpSpPr/>
       <p:sp>
         <p:nvSpPr>
-          <p:cNvPr id="2" name="Title 1"/>
-          <p:cNvSpPr>
-            <a:spLocks noGrp="1"/>
-          </p:cNvSpPr>
-          <p:nvPr>
-            <p:ph type="ctrTitle"/>
-          </p:nvPr>
-        </p:nvSpPr>
-        <p:spPr/>
-        <p:txBody>
-          <a:bodyPr/>
-          <a:lstStyle/>
-          <a:p>
-            <a:r>
-              <a:rPr sz="3600" b="1">
+          <p:cNvPr id="2" name="TextBox 1"/>
+          <p:cNvSpPr txBox="1"/>
+          <p:nvPr/>
+        </p:nvSpPr>
+        <p:spPr>
+          <a:xfrm>
+            <a:off x="914400" y="1828800"/>
+            <a:ext cx="10058400" cy="1371600"/>
+          </a:xfrm>
+          <a:prstGeom prst="rect">
+            <a:avLst/>
+          </a:prstGeom>
+          <a:noFill/>
+        </p:spPr>
+        <p:txBody>
+          <a:bodyPr wrap="square">
+            <a:spAutoFit/>
+          </a:bodyPr>
+          <a:lstStyle/>
+          <a:p>
+            <a:pPr algn="l">
+              <a:defRPr sz="4400" b="1">
                 <a:solidFill>
-                  <a:srgbClr val="003366"/>
+                  <a:srgbClr val="FFFFFF"/>
                 </a:solidFill>
-              </a:rPr>
+                <a:latin typeface="Calibri"/>
+              </a:defRPr>
+            </a:pPr>
+            <a:r>
               <a:t>UIAO Documentation</a:t>
             </a:r>
           </a:p>
@@ -3116,26 +3138,772 @@
       </p:sp>
       <p:sp>
         <p:nvSpPr>
-          <p:cNvPr id="3" name="Subtitle 2"/>
-          <p:cNvSpPr>
-            <a:spLocks noGrp="1"/>
-          </p:cNvSpPr>
-          <p:nvPr>
-            <p:ph type="subTitle" idx="1"/>
-          </p:nvPr>
-        </p:nvSpPr>
-        <p:spPr/>
-        <p:txBody>
-          <a:bodyPr/>
-          <a:lstStyle/>
-          <a:p>
-            <a:r>
-              <a:rPr sz="2000">
+          <p:cNvPr id="3" name="TextBox 2"/>
+          <p:cNvSpPr txBox="1"/>
+          <p:nvPr/>
+        </p:nvSpPr>
+        <p:spPr>
+          <a:xfrm>
+            <a:off x="914400" y="3200400"/>
+            <a:ext cx="10058400" cy="914400"/>
+          </a:xfrm>
+          <a:prstGeom prst="rect">
+            <a:avLst/>
+          </a:prstGeom>
+          <a:noFill/>
+        </p:spPr>
+        <p:txBody>
+          <a:bodyPr wrap="square">
+            <a:spAutoFit/>
+          </a:bodyPr>
+          <a:lstStyle/>
+          <a:p>
+            <a:pPr algn="l">
+              <a:defRPr sz="2200" b="0">
+                <a:solidFill>
+                  <a:srgbClr val="BBCCDD"/>
+                </a:solidFill>
+                <a:latin typeface="Calibri"/>
+              </a:defRPr>
+            </a:pPr>
+            <a:r>
+              <a:t>Unified Identity-Addressing-Overlay Architecture</a:t>
+            </a:r>
+          </a:p>
+        </p:txBody>
+      </p:sp>
+      <p:sp>
+        <p:nvSpPr>
+          <p:cNvPr id="4" name="Rectangle 3"/>
+          <p:cNvSpPr/>
+          <p:nvPr/>
+        </p:nvSpPr>
+        <p:spPr>
+          <a:xfrm>
+            <a:off x="914400" y="3017520"/>
+            <a:ext cx="2743200" cy="38100"/>
+          </a:xfrm>
+          <a:prstGeom prst="rect">
+            <a:avLst/>
+          </a:prstGeom>
+          <a:solidFill>
+            <a:srgbClr val="0078D4"/>
+          </a:solidFill>
+          <a:ln>
+            <a:noFill/>
+          </a:ln>
+        </p:spPr>
+        <p:style>
+          <a:lnRef idx="1">
+            <a:schemeClr val="accent1"/>
+          </a:lnRef>
+          <a:fillRef idx="3">
+            <a:schemeClr val="accent1"/>
+          </a:fillRef>
+          <a:effectRef idx="2">
+            <a:schemeClr val="accent1"/>
+          </a:effectRef>
+          <a:fontRef idx="minor">
+            <a:schemeClr val="lt1"/>
+          </a:fontRef>
+        </p:style>
+        <p:txBody>
+          <a:bodyPr rtlCol="0" anchor="ctr"/>
+          <a:lstStyle/>
+          <a:p>
+            <a:pPr algn="ctr"/>
+          </a:p>
+        </p:txBody>
+      </p:sp>
+      <p:sp>
+        <p:nvSpPr>
+          <p:cNvPr id="5" name="TextBox 4"/>
+          <p:cNvSpPr txBox="1"/>
+          <p:nvPr/>
+        </p:nvSpPr>
+        <p:spPr>
+          <a:xfrm>
+            <a:off x="914400" y="5029200"/>
+            <a:ext cx="10058400" cy="457200"/>
+          </a:xfrm>
+          <a:prstGeom prst="rect">
+            <a:avLst/>
+          </a:prstGeom>
+          <a:noFill/>
+        </p:spPr>
+        <p:txBody>
+          <a:bodyPr wrap="square">
+            <a:spAutoFit/>
+          </a:bodyPr>
+          <a:lstStyle/>
+          <a:p>
+            <a:pPr algn="l">
+              <a:defRPr sz="1400" b="0">
+                <a:solidFill>
+                  <a:srgbClr val="8899AA"/>
+                </a:solidFill>
+                <a:latin typeface="Calibri"/>
+              </a:defRPr>
+            </a:pPr>
+            <a:r>
+              <a:t>UIAO Modernization Program</a:t>
+            </a:r>
+          </a:p>
+        </p:txBody>
+      </p:sp>
+    </p:spTree>
+  </p:cSld>
+  <p:clrMapOvr>
+    <a:masterClrMapping/>
+  </p:clrMapOvr>
+</p:sld>
+</file>
+
+<file path=ppt/slides/slide2.xml><?xml version="1.0" encoding="utf-8"?>
+<p:sld xmlns:a="http://schemas.openxmlformats.org/drawingml/2006/main" xmlns:p="http://schemas.openxmlformats.org/presentationml/2006/main" xmlns:r="http://schemas.openxmlformats.org/officeDocument/2006/relationships">
+  <p:cSld>
+    <p:bg>
+      <p:bgPr>
+        <a:solidFill>
+          <a:srgbClr val="FFFFFF"/>
+        </a:solidFill>
+        <a:effectLst/>
+      </p:bgPr>
+    </p:bg>
+    <p:spTree>
+      <p:nvGrpSpPr>
+        <p:cNvPr id="1" name=""/>
+        <p:cNvGrpSpPr/>
+        <p:nvPr/>
+      </p:nvGrpSpPr>
+      <p:grpSpPr/>
+      <p:sp>
+        <p:nvSpPr>
+          <p:cNvPr id="2" name="Rectangle 1"/>
+          <p:cNvSpPr/>
+          <p:nvPr/>
+        </p:nvSpPr>
+        <p:spPr>
+          <a:xfrm>
+            <a:off x="0" y="0"/>
+            <a:ext cx="12191695" cy="457200"/>
+          </a:xfrm>
+          <a:prstGeom prst="rect">
+            <a:avLst/>
+          </a:prstGeom>
+          <a:solidFill>
+            <a:srgbClr val="003B6F"/>
+          </a:solidFill>
+          <a:ln>
+            <a:noFill/>
+          </a:ln>
+        </p:spPr>
+        <p:style>
+          <a:lnRef idx="1">
+            <a:schemeClr val="accent1"/>
+          </a:lnRef>
+          <a:fillRef idx="3">
+            <a:schemeClr val="accent1"/>
+          </a:fillRef>
+          <a:effectRef idx="2">
+            <a:schemeClr val="accent1"/>
+          </a:effectRef>
+          <a:fontRef idx="minor">
+            <a:schemeClr val="lt1"/>
+          </a:fontRef>
+        </p:style>
+        <p:txBody>
+          <a:bodyPr rtlCol="0" anchor="ctr"/>
+          <a:lstStyle/>
+          <a:p>
+            <a:pPr algn="ctr"/>
+          </a:p>
+        </p:txBody>
+      </p:sp>
+      <p:sp>
+        <p:nvSpPr>
+          <p:cNvPr id="3" name="TextBox 2"/>
+          <p:cNvSpPr txBox="1"/>
+          <p:nvPr/>
+        </p:nvSpPr>
+        <p:spPr>
+          <a:xfrm>
+            <a:off x="914400" y="2286000"/>
+            <a:ext cx="10058400" cy="1371600"/>
+          </a:xfrm>
+          <a:prstGeom prst="rect">
+            <a:avLst/>
+          </a:prstGeom>
+          <a:noFill/>
+        </p:spPr>
+        <p:txBody>
+          <a:bodyPr wrap="square">
+            <a:spAutoFit/>
+          </a:bodyPr>
+          <a:lstStyle/>
+          <a:p>
+            <a:pPr algn="l">
+              <a:defRPr sz="3600" b="1">
+                <a:solidFill>
+                  <a:srgbClr val="003B6F"/>
+                </a:solidFill>
+                <a:latin typeface="Calibri"/>
+              </a:defRPr>
+            </a:pPr>
+            <a:r>
+              <a:t>Section Title</a:t>
+            </a:r>
+          </a:p>
+        </p:txBody>
+      </p:sp>
+      <p:sp>
+        <p:nvSpPr>
+          <p:cNvPr id="4" name="Rectangle 3"/>
+          <p:cNvSpPr/>
+          <p:nvPr/>
+        </p:nvSpPr>
+        <p:spPr>
+          <a:xfrm>
+            <a:off x="914400" y="3657600"/>
+            <a:ext cx="1828800" cy="38100"/>
+          </a:xfrm>
+          <a:prstGeom prst="rect">
+            <a:avLst/>
+          </a:prstGeom>
+          <a:solidFill>
+            <a:srgbClr val="0078D4"/>
+          </a:solidFill>
+          <a:ln>
+            <a:noFill/>
+          </a:ln>
+        </p:spPr>
+        <p:style>
+          <a:lnRef idx="1">
+            <a:schemeClr val="accent1"/>
+          </a:lnRef>
+          <a:fillRef idx="3">
+            <a:schemeClr val="accent1"/>
+          </a:fillRef>
+          <a:effectRef idx="2">
+            <a:schemeClr val="accent1"/>
+          </a:effectRef>
+          <a:fontRef idx="minor">
+            <a:schemeClr val="lt1"/>
+          </a:fontRef>
+        </p:style>
+        <p:txBody>
+          <a:bodyPr rtlCol="0" anchor="ctr"/>
+          <a:lstStyle/>
+          <a:p>
+            <a:pPr algn="ctr"/>
+          </a:p>
+        </p:txBody>
+      </p:sp>
+    </p:spTree>
+  </p:cSld>
+  <p:clrMapOvr>
+    <a:masterClrMapping/>
+  </p:clrMapOvr>
+</p:sld>
+</file>
+
+<file path=ppt/slides/slide3.xml><?xml version="1.0" encoding="utf-8"?>
+<p:sld xmlns:a="http://schemas.openxmlformats.org/drawingml/2006/main" xmlns:p="http://schemas.openxmlformats.org/presentationml/2006/main" xmlns:r="http://schemas.openxmlformats.org/officeDocument/2006/relationships">
+  <p:cSld>
+    <p:bg>
+      <p:bgPr>
+        <a:solidFill>
+          <a:srgbClr val="FFFFFF"/>
+        </a:solidFill>
+        <a:effectLst/>
+      </p:bgPr>
+    </p:bg>
+    <p:spTree>
+      <p:nvGrpSpPr>
+        <p:cNvPr id="1" name=""/>
+        <p:cNvGrpSpPr/>
+        <p:nvPr/>
+      </p:nvGrpSpPr>
+      <p:grpSpPr/>
+      <p:sp>
+        <p:nvSpPr>
+          <p:cNvPr id="2" name="Rectangle 1"/>
+          <p:cNvSpPr/>
+          <p:nvPr/>
+        </p:nvSpPr>
+        <p:spPr>
+          <a:xfrm>
+            <a:off x="0" y="0"/>
+            <a:ext cx="12191695" cy="457200"/>
+          </a:xfrm>
+          <a:prstGeom prst="rect">
+            <a:avLst/>
+          </a:prstGeom>
+          <a:solidFill>
+            <a:srgbClr val="003B6F"/>
+          </a:solidFill>
+          <a:ln>
+            <a:noFill/>
+          </a:ln>
+        </p:spPr>
+        <p:style>
+          <a:lnRef idx="1">
+            <a:schemeClr val="accent1"/>
+          </a:lnRef>
+          <a:fillRef idx="3">
+            <a:schemeClr val="accent1"/>
+          </a:fillRef>
+          <a:effectRef idx="2">
+            <a:schemeClr val="accent1"/>
+          </a:effectRef>
+          <a:fontRef idx="minor">
+            <a:schemeClr val="lt1"/>
+          </a:fontRef>
+        </p:style>
+        <p:txBody>
+          <a:bodyPr rtlCol="0" anchor="ctr"/>
+          <a:lstStyle/>
+          <a:p>
+            <a:pPr algn="ctr"/>
+          </a:p>
+        </p:txBody>
+      </p:sp>
+      <p:sp>
+        <p:nvSpPr>
+          <p:cNvPr id="3" name="TextBox 2"/>
+          <p:cNvSpPr txBox="1"/>
+          <p:nvPr/>
+        </p:nvSpPr>
+        <p:spPr>
+          <a:xfrm>
+            <a:off x="731520" y="640080"/>
+            <a:ext cx="10515600" cy="731520"/>
+          </a:xfrm>
+          <a:prstGeom prst="rect">
+            <a:avLst/>
+          </a:prstGeom>
+          <a:noFill/>
+        </p:spPr>
+        <p:txBody>
+          <a:bodyPr wrap="square">
+            <a:spAutoFit/>
+          </a:bodyPr>
+          <a:lstStyle/>
+          <a:p>
+            <a:pPr algn="l">
+              <a:defRPr sz="2800" b="1">
+                <a:solidFill>
+                  <a:srgbClr val="003B6F"/>
+                </a:solidFill>
+                <a:latin typeface="Calibri"/>
+              </a:defRPr>
+            </a:pPr>
+            <a:r>
+              <a:t>Slide Title</a:t>
+            </a:r>
+          </a:p>
+        </p:txBody>
+      </p:sp>
+      <p:sp>
+        <p:nvSpPr>
+          <p:cNvPr id="4" name="Rectangle 3"/>
+          <p:cNvSpPr/>
+          <p:nvPr/>
+        </p:nvSpPr>
+        <p:spPr>
+          <a:xfrm>
+            <a:off x="731520" y="1371600"/>
+            <a:ext cx="10515600" cy="38100"/>
+          </a:xfrm>
+          <a:prstGeom prst="rect">
+            <a:avLst/>
+          </a:prstGeom>
+          <a:solidFill>
+            <a:srgbClr val="DDDDDD"/>
+          </a:solidFill>
+          <a:ln>
+            <a:noFill/>
+          </a:ln>
+        </p:spPr>
+        <p:style>
+          <a:lnRef idx="1">
+            <a:schemeClr val="accent1"/>
+          </a:lnRef>
+          <a:fillRef idx="3">
+            <a:schemeClr val="accent1"/>
+          </a:fillRef>
+          <a:effectRef idx="2">
+            <a:schemeClr val="accent1"/>
+          </a:effectRef>
+          <a:fontRef idx="minor">
+            <a:schemeClr val="lt1"/>
+          </a:fontRef>
+        </p:style>
+        <p:txBody>
+          <a:bodyPr rtlCol="0" anchor="ctr"/>
+          <a:lstStyle/>
+          <a:p>
+            <a:pPr algn="ctr"/>
+          </a:p>
+        </p:txBody>
+      </p:sp>
+      <p:sp>
+        <p:nvSpPr>
+          <p:cNvPr id="5" name="TextBox 4"/>
+          <p:cNvSpPr txBox="1"/>
+          <p:nvPr/>
+        </p:nvSpPr>
+        <p:spPr>
+          <a:xfrm>
+            <a:off x="731520" y="1645920"/>
+            <a:ext cx="10515600" cy="4572000"/>
+          </a:xfrm>
+          <a:prstGeom prst="rect">
+            <a:avLst/>
+          </a:prstGeom>
+          <a:noFill/>
+        </p:spPr>
+        <p:txBody>
+          <a:bodyPr wrap="square">
+            <a:spAutoFit/>
+          </a:bodyPr>
+          <a:lstStyle/>
+          <a:p>
+            <a:pPr algn="l">
+              <a:defRPr sz="1800" b="0">
                 <a:solidFill>
                   <a:srgbClr val="333333"/>
                 </a:solidFill>
-              </a:rPr>
-              <a:t>Unified Identity-Addressing-Overlay</a:t>
+                <a:latin typeface="Calibri"/>
+              </a:defRPr>
+            </a:pPr>
+            <a:r>
+              <a:t>Content goes here. Quarto maps markdown content to this area.</a:t>
+            </a:r>
+          </a:p>
+        </p:txBody>
+      </p:sp>
+    </p:spTree>
+  </p:cSld>
+  <p:clrMapOvr>
+    <a:masterClrMapping/>
+  </p:clrMapOvr>
+</p:sld>
+</file>
+
+<file path=ppt/slides/slide4.xml><?xml version="1.0" encoding="utf-8"?>
+<p:sld xmlns:a="http://schemas.openxmlformats.org/drawingml/2006/main" xmlns:p="http://schemas.openxmlformats.org/presentationml/2006/main" xmlns:r="http://schemas.openxmlformats.org/officeDocument/2006/relationships">
+  <p:cSld>
+    <p:bg>
+      <p:bgPr>
+        <a:solidFill>
+          <a:srgbClr val="FFFFFF"/>
+        </a:solidFill>
+        <a:effectLst/>
+      </p:bgPr>
+    </p:bg>
+    <p:spTree>
+      <p:nvGrpSpPr>
+        <p:cNvPr id="1" name=""/>
+        <p:cNvGrpSpPr/>
+        <p:nvPr/>
+      </p:nvGrpSpPr>
+      <p:grpSpPr/>
+      <p:sp>
+        <p:nvSpPr>
+          <p:cNvPr id="2" name="Rectangle 1"/>
+          <p:cNvSpPr/>
+          <p:nvPr/>
+        </p:nvSpPr>
+        <p:spPr>
+          <a:xfrm>
+            <a:off x="0" y="0"/>
+            <a:ext cx="12191695" cy="457200"/>
+          </a:xfrm>
+          <a:prstGeom prst="rect">
+            <a:avLst/>
+          </a:prstGeom>
+          <a:solidFill>
+            <a:srgbClr val="003B6F"/>
+          </a:solidFill>
+          <a:ln>
+            <a:noFill/>
+          </a:ln>
+        </p:spPr>
+        <p:style>
+          <a:lnRef idx="1">
+            <a:schemeClr val="accent1"/>
+          </a:lnRef>
+          <a:fillRef idx="3">
+            <a:schemeClr val="accent1"/>
+          </a:fillRef>
+          <a:effectRef idx="2">
+            <a:schemeClr val="accent1"/>
+          </a:effectRef>
+          <a:fontRef idx="minor">
+            <a:schemeClr val="lt1"/>
+          </a:fontRef>
+        </p:style>
+        <p:txBody>
+          <a:bodyPr rtlCol="0" anchor="ctr"/>
+          <a:lstStyle/>
+          <a:p>
+            <a:pPr algn="ctr"/>
+          </a:p>
+        </p:txBody>
+      </p:sp>
+      <p:sp>
+        <p:nvSpPr>
+          <p:cNvPr id="3" name="TextBox 2"/>
+          <p:cNvSpPr txBox="1"/>
+          <p:nvPr/>
+        </p:nvSpPr>
+        <p:spPr>
+          <a:xfrm>
+            <a:off x="731520" y="640080"/>
+            <a:ext cx="10515600" cy="731520"/>
+          </a:xfrm>
+          <a:prstGeom prst="rect">
+            <a:avLst/>
+          </a:prstGeom>
+          <a:noFill/>
+        </p:spPr>
+        <p:txBody>
+          <a:bodyPr wrap="square">
+            <a:spAutoFit/>
+          </a:bodyPr>
+          <a:lstStyle/>
+          <a:p>
+            <a:pPr algn="l">
+              <a:defRPr sz="2800" b="1">
+                <a:solidFill>
+                  <a:srgbClr val="003B6F"/>
+                </a:solidFill>
+                <a:latin typeface="Calibri"/>
+              </a:defRPr>
+            </a:pPr>
+            <a:r>
+              <a:t>Two Column Layout</a:t>
+            </a:r>
+          </a:p>
+        </p:txBody>
+      </p:sp>
+      <p:sp>
+        <p:nvSpPr>
+          <p:cNvPr id="4" name="Rectangle 3"/>
+          <p:cNvSpPr/>
+          <p:nvPr/>
+        </p:nvSpPr>
+        <p:spPr>
+          <a:xfrm>
+            <a:off x="731520" y="1371600"/>
+            <a:ext cx="10515600" cy="38100"/>
+          </a:xfrm>
+          <a:prstGeom prst="rect">
+            <a:avLst/>
+          </a:prstGeom>
+          <a:solidFill>
+            <a:srgbClr val="DDDDDD"/>
+          </a:solidFill>
+          <a:ln>
+            <a:noFill/>
+          </a:ln>
+        </p:spPr>
+        <p:style>
+          <a:lnRef idx="1">
+            <a:schemeClr val="accent1"/>
+          </a:lnRef>
+          <a:fillRef idx="3">
+            <a:schemeClr val="accent1"/>
+          </a:fillRef>
+          <a:effectRef idx="2">
+            <a:schemeClr val="accent1"/>
+          </a:effectRef>
+          <a:fontRef idx="minor">
+            <a:schemeClr val="lt1"/>
+          </a:fontRef>
+        </p:style>
+        <p:txBody>
+          <a:bodyPr rtlCol="0" anchor="ctr"/>
+          <a:lstStyle/>
+          <a:p>
+            <a:pPr algn="ctr"/>
+          </a:p>
+        </p:txBody>
+      </p:sp>
+      <p:sp>
+        <p:nvSpPr>
+          <p:cNvPr id="5" name="TextBox 4"/>
+          <p:cNvSpPr txBox="1"/>
+          <p:nvPr/>
+        </p:nvSpPr>
+        <p:spPr>
+          <a:xfrm>
+            <a:off x="731520" y="1645920"/>
+            <a:ext cx="5029200" cy="4572000"/>
+          </a:xfrm>
+          <a:prstGeom prst="rect">
+            <a:avLst/>
+          </a:prstGeom>
+          <a:noFill/>
+        </p:spPr>
+        <p:txBody>
+          <a:bodyPr wrap="square">
+            <a:spAutoFit/>
+          </a:bodyPr>
+          <a:lstStyle/>
+          <a:p>
+            <a:pPr algn="l">
+              <a:defRPr sz="1800" b="0">
+                <a:solidFill>
+                  <a:srgbClr val="333333"/>
+                </a:solidFill>
+                <a:latin typeface="Calibri"/>
+              </a:defRPr>
+            </a:pPr>
+            <a:r>
+              <a:t>Left column content</a:t>
+            </a:r>
+          </a:p>
+        </p:txBody>
+      </p:sp>
+      <p:sp>
+        <p:nvSpPr>
+          <p:cNvPr id="6" name="TextBox 5"/>
+          <p:cNvSpPr txBox="1"/>
+          <p:nvPr/>
+        </p:nvSpPr>
+        <p:spPr>
+          <a:xfrm>
+            <a:off x="6400800" y="1645920"/>
+            <a:ext cx="5029200" cy="4572000"/>
+          </a:xfrm>
+          <a:prstGeom prst="rect">
+            <a:avLst/>
+          </a:prstGeom>
+          <a:noFill/>
+        </p:spPr>
+        <p:txBody>
+          <a:bodyPr wrap="square">
+            <a:spAutoFit/>
+          </a:bodyPr>
+          <a:lstStyle/>
+          <a:p>
+            <a:pPr algn="l">
+              <a:defRPr sz="1800" b="0">
+                <a:solidFill>
+                  <a:srgbClr val="333333"/>
+                </a:solidFill>
+                <a:latin typeface="Calibri"/>
+              </a:defRPr>
+            </a:pPr>
+            <a:r>
+              <a:t>Right column content</a:t>
+            </a:r>
+          </a:p>
+        </p:txBody>
+      </p:sp>
+    </p:spTree>
+  </p:cSld>
+  <p:clrMapOvr>
+    <a:masterClrMapping/>
+  </p:clrMapOvr>
+</p:sld>
+</file>
+
+<file path=ppt/slides/slide5.xml><?xml version="1.0" encoding="utf-8"?>
+<p:sld xmlns:a="http://schemas.openxmlformats.org/drawingml/2006/main" xmlns:p="http://schemas.openxmlformats.org/presentationml/2006/main" xmlns:r="http://schemas.openxmlformats.org/officeDocument/2006/relationships">
+  <p:cSld>
+    <p:bg>
+      <p:bgPr>
+        <a:solidFill>
+          <a:srgbClr val="FFFFFF"/>
+        </a:solidFill>
+        <a:effectLst/>
+      </p:bgPr>
+    </p:bg>
+    <p:spTree>
+      <p:nvGrpSpPr>
+        <p:cNvPr id="1" name=""/>
+        <p:cNvGrpSpPr/>
+        <p:nvPr/>
+      </p:nvGrpSpPr>
+      <p:grpSpPr/>
+      <p:sp>
+        <p:nvSpPr>
+          <p:cNvPr id="2" name="Rectangle 1"/>
+          <p:cNvSpPr/>
+          <p:nvPr/>
+        </p:nvSpPr>
+        <p:spPr>
+          <a:xfrm>
+            <a:off x="0" y="0"/>
+            <a:ext cx="12191695" cy="457200"/>
+          </a:xfrm>
+          <a:prstGeom prst="rect">
+            <a:avLst/>
+          </a:prstGeom>
+          <a:solidFill>
+            <a:srgbClr val="003B6F"/>
+          </a:solidFill>
+          <a:ln>
+            <a:noFill/>
+          </a:ln>
+        </p:spPr>
+        <p:style>
+          <a:lnRef idx="1">
+            <a:schemeClr val="accent1"/>
+          </a:lnRef>
+          <a:fillRef idx="3">
+            <a:schemeClr val="accent1"/>
+          </a:fillRef>
+          <a:effectRef idx="2">
+            <a:schemeClr val="accent1"/>
+          </a:effectRef>
+          <a:fontRef idx="minor">
+            <a:schemeClr val="lt1"/>
+          </a:fontRef>
+        </p:style>
+        <p:txBody>
+          <a:bodyPr rtlCol="0" anchor="ctr"/>
+          <a:lstStyle/>
+          <a:p>
+            <a:pPr algn="ctr"/>
+          </a:p>
+        </p:txBody>
+      </p:sp>
+      <p:sp>
+        <p:nvSpPr>
+          <p:cNvPr id="3" name="TextBox 2"/>
+          <p:cNvSpPr txBox="1"/>
+          <p:nvPr/>
+        </p:nvSpPr>
+        <p:spPr>
+          <a:xfrm>
+            <a:off x="731520" y="6217920"/>
+            <a:ext cx="4572000" cy="365760"/>
+          </a:xfrm>
+          <a:prstGeom prst="rect">
+            <a:avLst/>
+          </a:prstGeom>
+          <a:noFill/>
+        </p:spPr>
+        <p:txBody>
+          <a:bodyPr wrap="square">
+            <a:spAutoFit/>
+          </a:bodyPr>
+          <a:lstStyle/>
+          <a:p>
+            <a:pPr algn="l">
+              <a:defRPr sz="1000" b="0">
+                <a:solidFill>
+                  <a:srgbClr val="999999"/>
+                </a:solidFill>
+                <a:latin typeface="Calibri"/>
+              </a:defRPr>
+            </a:pPr>
+            <a:r>
+              <a:t>UIAO Modernization Program</a:t>
             </a:r>
           </a:p>
         </p:txBody>

</xml_diff>